<commit_message>
number of segments- update with latest changes from laptop
</commit_message>
<xml_diff>
--- a/7-24-2025.pptx
+++ b/7-24-2025.pptx
@@ -5,10 +5,10 @@
     <p:sldMasterId id="2147483668" r:id="rId4"/>
   </p:sldMasterIdLst>
   <p:notesMasterIdLst>
-    <p:notesMasterId r:id="rId14"/>
+    <p:notesMasterId r:id="rId15"/>
   </p:notesMasterIdLst>
   <p:handoutMasterIdLst>
-    <p:handoutMasterId r:id="rId15"/>
+    <p:handoutMasterId r:id="rId16"/>
   </p:handoutMasterIdLst>
   <p:sldIdLst>
     <p:sldId id="256" r:id="rId5"/>
@@ -17,9 +17,10 @@
     <p:sldId id="260" r:id="rId8"/>
     <p:sldId id="265" r:id="rId9"/>
     <p:sldId id="262" r:id="rId10"/>
-    <p:sldId id="261" r:id="rId11"/>
-    <p:sldId id="263" r:id="rId12"/>
-    <p:sldId id="264" r:id="rId13"/>
+    <p:sldId id="266" r:id="rId11"/>
+    <p:sldId id="261" r:id="rId12"/>
+    <p:sldId id="263" r:id="rId13"/>
+    <p:sldId id="264" r:id="rId14"/>
   </p:sldIdLst>
   <p:sldSz cx="12192000" cy="6858000"/>
   <p:notesSz cx="6858000" cy="9144000"/>
@@ -11290,6 +11291,156 @@
 </p:sld>
 </file>
 
+<file path=ppt/slides/slide10.xml><?xml version="1.0" encoding="utf-8"?>
+<p:sld xmlns:a="http://schemas.openxmlformats.org/drawingml/2006/main" xmlns:r="http://schemas.openxmlformats.org/officeDocument/2006/relationships" xmlns:p="http://schemas.openxmlformats.org/presentationml/2006/main">
+  <p:cSld>
+    <p:spTree>
+      <p:nvGrpSpPr>
+        <p:cNvPr id="1" name=""/>
+        <p:cNvGrpSpPr/>
+        <p:nvPr/>
+      </p:nvGrpSpPr>
+      <p:grpSpPr>
+        <a:xfrm>
+          <a:off x="0" y="0"/>
+          <a:ext cx="0" cy="0"/>
+          <a:chOff x="0" y="0"/>
+          <a:chExt cx="0" cy="0"/>
+        </a:xfrm>
+      </p:grpSpPr>
+      <p:sp>
+        <p:nvSpPr>
+          <p:cNvPr id="2" name="Title 1">
+            <a:extLst>
+              <a:ext uri="{FF2B5EF4-FFF2-40B4-BE49-F238E27FC236}">
+                <a16:creationId xmlns:a16="http://schemas.microsoft.com/office/drawing/2014/main" id="{E767BCE7-0161-5562-4264-F54B5E10E5DE}"/>
+              </a:ext>
+            </a:extLst>
+          </p:cNvPr>
+          <p:cNvSpPr>
+            <a:spLocks noGrp="1"/>
+          </p:cNvSpPr>
+          <p:nvPr>
+            <p:ph type="title"/>
+          </p:nvPr>
+        </p:nvSpPr>
+        <p:spPr/>
+        <p:txBody>
+          <a:bodyPr/>
+          <a:lstStyle/>
+          <a:p>
+            <a:endParaRPr lang="en-US"/>
+          </a:p>
+        </p:txBody>
+      </p:sp>
+      <p:pic>
+        <p:nvPicPr>
+          <p:cNvPr id="7" name="Content Placeholder 6">
+            <a:extLst>
+              <a:ext uri="{FF2B5EF4-FFF2-40B4-BE49-F238E27FC236}">
+                <a16:creationId xmlns:a16="http://schemas.microsoft.com/office/drawing/2014/main" id="{BE925136-C4D6-A05A-C48D-E90CCED4286D}"/>
+              </a:ext>
+            </a:extLst>
+          </p:cNvPr>
+          <p:cNvPicPr>
+            <a:picLocks noGrp="1" noChangeAspect="1"/>
+          </p:cNvPicPr>
+          <p:nvPr>
+            <p:ph idx="1"/>
+          </p:nvPr>
+        </p:nvPicPr>
+        <p:blipFill>
+          <a:blip r:embed="rId2"/>
+          <a:stretch>
+            <a:fillRect/>
+          </a:stretch>
+        </p:blipFill>
+        <p:spPr>
+          <a:xfrm>
+            <a:off x="2988920" y="1412875"/>
+            <a:ext cx="6112560" cy="4595813"/>
+          </a:xfrm>
+        </p:spPr>
+      </p:pic>
+      <p:sp>
+        <p:nvSpPr>
+          <p:cNvPr id="4" name="Footer Placeholder 3">
+            <a:extLst>
+              <a:ext uri="{FF2B5EF4-FFF2-40B4-BE49-F238E27FC236}">
+                <a16:creationId xmlns:a16="http://schemas.microsoft.com/office/drawing/2014/main" id="{59E5988A-40B5-3F36-E1F8-6EE758E64FCE}"/>
+              </a:ext>
+            </a:extLst>
+          </p:cNvPr>
+          <p:cNvSpPr>
+            <a:spLocks noGrp="1"/>
+          </p:cNvSpPr>
+          <p:nvPr>
+            <p:ph type="ftr" sz="quarter" idx="11"/>
+          </p:nvPr>
+        </p:nvSpPr>
+        <p:spPr/>
+        <p:txBody>
+          <a:bodyPr/>
+          <a:lstStyle/>
+          <a:p>
+            <a:r>
+              <a:rPr lang="en-US"/>
+              <a:t>Progress Update</a:t>
+            </a:r>
+            <a:endParaRPr lang="en-US" dirty="0"/>
+          </a:p>
+        </p:txBody>
+      </p:sp>
+      <p:sp>
+        <p:nvSpPr>
+          <p:cNvPr id="5" name="Slide Number Placeholder 4">
+            <a:extLst>
+              <a:ext uri="{FF2B5EF4-FFF2-40B4-BE49-F238E27FC236}">
+                <a16:creationId xmlns:a16="http://schemas.microsoft.com/office/drawing/2014/main" id="{1B5317DF-59D8-C380-9E0C-727E89A5B568}"/>
+              </a:ext>
+            </a:extLst>
+          </p:cNvPr>
+          <p:cNvSpPr>
+            <a:spLocks noGrp="1"/>
+          </p:cNvSpPr>
+          <p:nvPr>
+            <p:ph type="sldNum" sz="quarter" idx="12"/>
+          </p:nvPr>
+        </p:nvSpPr>
+        <p:spPr/>
+        <p:txBody>
+          <a:bodyPr/>
+          <a:lstStyle/>
+          <a:p>
+            <a:r>
+              <a:rPr lang="en-US"/>
+              <a:t>PAGE  </a:t>
+            </a:r>
+            <a:fld id="{93005692-73BE-493E-93AB-ECD6027A7652}" type="slidenum">
+              <a:rPr lang="en-US" smtClean="0"/>
+              <a:pPr/>
+              <a:t>10</a:t>
+            </a:fld>
+            <a:endParaRPr lang="en-US" dirty="0"/>
+          </a:p>
+        </p:txBody>
+      </p:sp>
+    </p:spTree>
+    <p:extLst>
+      <p:ext uri="{BB962C8B-B14F-4D97-AF65-F5344CB8AC3E}">
+        <p14:creationId xmlns:p14="http://schemas.microsoft.com/office/powerpoint/2010/main" val="1503759335"/>
+      </p:ext>
+    </p:extLst>
+  </p:cSld>
+  <p:clrMapOvr>
+    <a:masterClrMapping/>
+  </p:clrMapOvr>
+  <p:transition spd="slow">
+    <p:push dir="u"/>
+  </p:transition>
+</p:sld>
+</file>
+
 <file path=ppt/slides/slide2.xml><?xml version="1.0" encoding="utf-8"?>
 <p:sld xmlns:a="http://schemas.openxmlformats.org/drawingml/2006/main" xmlns:r="http://schemas.openxmlformats.org/officeDocument/2006/relationships" xmlns:p="http://schemas.openxmlformats.org/presentationml/2006/main">
   <p:cSld>
@@ -12069,7 +12220,7 @@
           <p:cNvPr id="2" name="Title 1">
             <a:extLst>
               <a:ext uri="{FF2B5EF4-FFF2-40B4-BE49-F238E27FC236}">
-                <a16:creationId xmlns:a16="http://schemas.microsoft.com/office/drawing/2014/main" id="{1BDF2226-05D7-8A11-1F1A-ED21417B6931}"/>
+                <a16:creationId xmlns:a16="http://schemas.microsoft.com/office/drawing/2014/main" id="{E5DD6952-5F03-5981-7BA3-4A31938DBE1D}"/>
               </a:ext>
             </a:extLst>
           </p:cNvPr>
@@ -12085,7 +12236,10 @@
           <a:bodyPr/>
           <a:lstStyle/>
           <a:p>
-            <a:endParaRPr lang="en-US"/>
+            <a:r>
+              <a:rPr lang="en-US" dirty="0"/>
+              <a:t>Scatter – abs – no subtraction from original linearized form</a:t>
+            </a:r>
           </a:p>
         </p:txBody>
       </p:sp>
@@ -12094,7 +12248,7 @@
           <p:cNvPr id="7" name="Content Placeholder 6">
             <a:extLst>
               <a:ext uri="{FF2B5EF4-FFF2-40B4-BE49-F238E27FC236}">
-                <a16:creationId xmlns:a16="http://schemas.microsoft.com/office/drawing/2014/main" id="{B76A86A8-BA88-A603-A96B-3B827CA1B34A}"/>
+                <a16:creationId xmlns:a16="http://schemas.microsoft.com/office/drawing/2014/main" id="{3C3F32A8-CD24-444C-CEEA-0787DA0B0949}"/>
               </a:ext>
             </a:extLst>
           </p:cNvPr>
@@ -12113,8 +12267,8 @@
         </p:blipFill>
         <p:spPr>
           <a:xfrm>
-            <a:off x="3134906" y="1453041"/>
-            <a:ext cx="5820587" cy="4515480"/>
+            <a:off x="1982829" y="1412875"/>
+            <a:ext cx="8124741" cy="4595813"/>
           </a:xfrm>
         </p:spPr>
       </p:pic>
@@ -12123,7 +12277,7 @@
           <p:cNvPr id="4" name="Footer Placeholder 3">
             <a:extLst>
               <a:ext uri="{FF2B5EF4-FFF2-40B4-BE49-F238E27FC236}">
-                <a16:creationId xmlns:a16="http://schemas.microsoft.com/office/drawing/2014/main" id="{C75A2551-033E-AB25-0B85-35BFB7AF9BB5}"/>
+                <a16:creationId xmlns:a16="http://schemas.microsoft.com/office/drawing/2014/main" id="{C62B374A-AD3D-AAC5-DF7C-1DD0D46C7390}"/>
               </a:ext>
             </a:extLst>
           </p:cNvPr>
@@ -12152,7 +12306,7 @@
           <p:cNvPr id="5" name="Slide Number Placeholder 4">
             <a:extLst>
               <a:ext uri="{FF2B5EF4-FFF2-40B4-BE49-F238E27FC236}">
-                <a16:creationId xmlns:a16="http://schemas.microsoft.com/office/drawing/2014/main" id="{92A4A1D0-A13F-C868-BFE2-B3057842944B}"/>
+                <a16:creationId xmlns:a16="http://schemas.microsoft.com/office/drawing/2014/main" id="{F319092F-33D3-EA74-E90F-C9F493589578}"/>
               </a:ext>
             </a:extLst>
           </p:cNvPr>
@@ -12184,7 +12338,7 @@
     </p:spTree>
     <p:extLst>
       <p:ext uri="{BB962C8B-B14F-4D97-AF65-F5344CB8AC3E}">
-        <p14:creationId xmlns:p14="http://schemas.microsoft.com/office/powerpoint/2010/main" val="2392747901"/>
+        <p14:creationId xmlns:p14="http://schemas.microsoft.com/office/powerpoint/2010/main" val="2876213698"/>
       </p:ext>
     </p:extLst>
   </p:cSld>
@@ -12219,7 +12373,7 @@
           <p:cNvPr id="2" name="Title 1">
             <a:extLst>
               <a:ext uri="{FF2B5EF4-FFF2-40B4-BE49-F238E27FC236}">
-                <a16:creationId xmlns:a16="http://schemas.microsoft.com/office/drawing/2014/main" id="{6CDAA2C5-D6D4-B817-D89D-8F3D75B545E1}"/>
+                <a16:creationId xmlns:a16="http://schemas.microsoft.com/office/drawing/2014/main" id="{1BDF2226-05D7-8A11-1F1A-ED21417B6931}"/>
               </a:ext>
             </a:extLst>
           </p:cNvPr>
@@ -12244,7 +12398,7 @@
           <p:cNvPr id="7" name="Content Placeholder 6">
             <a:extLst>
               <a:ext uri="{FF2B5EF4-FFF2-40B4-BE49-F238E27FC236}">
-                <a16:creationId xmlns:a16="http://schemas.microsoft.com/office/drawing/2014/main" id="{73EC4068-2A52-FFDC-F3C6-5A6ACE29979A}"/>
+                <a16:creationId xmlns:a16="http://schemas.microsoft.com/office/drawing/2014/main" id="{B76A86A8-BA88-A603-A96B-3B827CA1B34A}"/>
               </a:ext>
             </a:extLst>
           </p:cNvPr>
@@ -12263,8 +12417,8 @@
         </p:blipFill>
         <p:spPr>
           <a:xfrm>
-            <a:off x="2420160" y="1412875"/>
-            <a:ext cx="7250079" cy="4595813"/>
+            <a:off x="3134906" y="1453041"/>
+            <a:ext cx="5820587" cy="4515480"/>
           </a:xfrm>
         </p:spPr>
       </p:pic>
@@ -12273,7 +12427,7 @@
           <p:cNvPr id="4" name="Footer Placeholder 3">
             <a:extLst>
               <a:ext uri="{FF2B5EF4-FFF2-40B4-BE49-F238E27FC236}">
-                <a16:creationId xmlns:a16="http://schemas.microsoft.com/office/drawing/2014/main" id="{43E56FF8-6B36-0163-6AD2-46D40477D0AB}"/>
+                <a16:creationId xmlns:a16="http://schemas.microsoft.com/office/drawing/2014/main" id="{C75A2551-033E-AB25-0B85-35BFB7AF9BB5}"/>
               </a:ext>
             </a:extLst>
           </p:cNvPr>
@@ -12302,7 +12456,7 @@
           <p:cNvPr id="5" name="Slide Number Placeholder 4">
             <a:extLst>
               <a:ext uri="{FF2B5EF4-FFF2-40B4-BE49-F238E27FC236}">
-                <a16:creationId xmlns:a16="http://schemas.microsoft.com/office/drawing/2014/main" id="{E313BE2D-5531-08BB-1513-9C021CCA9765}"/>
+                <a16:creationId xmlns:a16="http://schemas.microsoft.com/office/drawing/2014/main" id="{92A4A1D0-A13F-C868-BFE2-B3057842944B}"/>
               </a:ext>
             </a:extLst>
           </p:cNvPr>
@@ -12334,7 +12488,7 @@
     </p:spTree>
     <p:extLst>
       <p:ext uri="{BB962C8B-B14F-4D97-AF65-F5344CB8AC3E}">
-        <p14:creationId xmlns:p14="http://schemas.microsoft.com/office/powerpoint/2010/main" val="2448881242"/>
+        <p14:creationId xmlns:p14="http://schemas.microsoft.com/office/powerpoint/2010/main" val="2392747901"/>
       </p:ext>
     </p:extLst>
   </p:cSld>
@@ -12369,7 +12523,7 @@
           <p:cNvPr id="2" name="Title 1">
             <a:extLst>
               <a:ext uri="{FF2B5EF4-FFF2-40B4-BE49-F238E27FC236}">
-                <a16:creationId xmlns:a16="http://schemas.microsoft.com/office/drawing/2014/main" id="{E767BCE7-0161-5562-4264-F54B5E10E5DE}"/>
+                <a16:creationId xmlns:a16="http://schemas.microsoft.com/office/drawing/2014/main" id="{6CDAA2C5-D6D4-B817-D89D-8F3D75B545E1}"/>
               </a:ext>
             </a:extLst>
           </p:cNvPr>
@@ -12394,7 +12548,7 @@
           <p:cNvPr id="7" name="Content Placeholder 6">
             <a:extLst>
               <a:ext uri="{FF2B5EF4-FFF2-40B4-BE49-F238E27FC236}">
-                <a16:creationId xmlns:a16="http://schemas.microsoft.com/office/drawing/2014/main" id="{BE925136-C4D6-A05A-C48D-E90CCED4286D}"/>
+                <a16:creationId xmlns:a16="http://schemas.microsoft.com/office/drawing/2014/main" id="{73EC4068-2A52-FFDC-F3C6-5A6ACE29979A}"/>
               </a:ext>
             </a:extLst>
           </p:cNvPr>
@@ -12413,8 +12567,8 @@
         </p:blipFill>
         <p:spPr>
           <a:xfrm>
-            <a:off x="2988920" y="1412875"/>
-            <a:ext cx="6112560" cy="4595813"/>
+            <a:off x="2420160" y="1412875"/>
+            <a:ext cx="7250079" cy="4595813"/>
           </a:xfrm>
         </p:spPr>
       </p:pic>
@@ -12423,7 +12577,7 @@
           <p:cNvPr id="4" name="Footer Placeholder 3">
             <a:extLst>
               <a:ext uri="{FF2B5EF4-FFF2-40B4-BE49-F238E27FC236}">
-                <a16:creationId xmlns:a16="http://schemas.microsoft.com/office/drawing/2014/main" id="{59E5988A-40B5-3F36-E1F8-6EE758E64FCE}"/>
+                <a16:creationId xmlns:a16="http://schemas.microsoft.com/office/drawing/2014/main" id="{43E56FF8-6B36-0163-6AD2-46D40477D0AB}"/>
               </a:ext>
             </a:extLst>
           </p:cNvPr>
@@ -12452,7 +12606,7 @@
           <p:cNvPr id="5" name="Slide Number Placeholder 4">
             <a:extLst>
               <a:ext uri="{FF2B5EF4-FFF2-40B4-BE49-F238E27FC236}">
-                <a16:creationId xmlns:a16="http://schemas.microsoft.com/office/drawing/2014/main" id="{1B5317DF-59D8-C380-9E0C-727E89A5B568}"/>
+                <a16:creationId xmlns:a16="http://schemas.microsoft.com/office/drawing/2014/main" id="{E313BE2D-5531-08BB-1513-9C021CCA9765}"/>
               </a:ext>
             </a:extLst>
           </p:cNvPr>
@@ -12484,7 +12638,7 @@
     </p:spTree>
     <p:extLst>
       <p:ext uri="{BB962C8B-B14F-4D97-AF65-F5344CB8AC3E}">
-        <p14:creationId xmlns:p14="http://schemas.microsoft.com/office/powerpoint/2010/main" val="1503759335"/>
+        <p14:creationId xmlns:p14="http://schemas.microsoft.com/office/powerpoint/2010/main" val="2448881242"/>
       </p:ext>
     </p:extLst>
   </p:cSld>

</xml_diff>